<commit_message>
Day 2 deck round 7: value of the unknown into the bullets with MPI tile, advisor 50/50, opcodes column label
Co-Authored-By: Claude Opus 5.5 <noreply@anthropic.com>
Claude-Session: https://claude.ai/code/session_01Xa4nFVxuQGXmHARGph9WhS
</commit_message>
<xml_diff>
--- a/day2-deck/decks/Op Code Variance with Services - Review.pptx
+++ b/day2-deck/decks/Op Code Variance with Services - Review.pptx
@@ -505,7 +505,7 @@
           <a:p>
             <a:r>
               <a:rPr lang="en-US" dirty="0"/>
-              <a:t>Source: Qlik - Closed Repair Orders. Customer pay, Jan-Sep 2026 by close date, op code report basis. Same-store, INEOS excluded (opened 2026). Services short = benchmark x the store's CP ROs, minus the services it sold. Each service valued at the store's own labor + parts gross per service sold (group average where the store sold fewer than 30), capped at twice the group average because some flagged lines carry other work bundled on them. A year = Jan-Sep x 12 / 9. Stores at or above the benchmark are not shown and do not offset anyone. Alignment: every store, gross a year above (+) or below (-) the benchmark at the store's own gross per service. Rate = Jan-Sep closing %. Services = services a year above (+) or below (-) the benchmark (benchmark x CP ROs vs services sold, x 12/9).</a:t>
+              <a:t>Source: Qlik - Closed Repair Orders. Customer pay, Jan-Sep 2026 by close date, op code report basis. Same-store, INEOS excluded (opened 2026). Services short = benchmark x the store's CP ROs, minus the services it sold. Each service valued at the store's own labor + parts gross per service sold (group average where the store sold fewer than 30), capped at twice the group average because some flagged lines carry other work bundled on them. A year = Jan-Sep x 12 / 9. Stores at or above the benchmark are not shown and do not offset anyone. Alignment: every store, gross a year above (+) or below (-) the benchmark at the store's own gross per service. Rate = Jan-Sep closing %. Opcodes = opcodes a year above (+) or below (-) the benchmark (benchmark x CP ROs vs services sold, x 12/9).</a:t>
             </a:r>
             <a:endParaRPr lang="en-US" dirty="0"/>
           </a:p>
@@ -593,7 +593,7 @@
           <a:p>
             <a:r>
               <a:rPr lang="en-US" dirty="0"/>
-              <a:t>Source: Qlik - Closed Repair Orders. Customer pay, Jan-Sep 2026 by close date, op code report basis. Same-store, INEOS excluded (opened 2026). Services short = benchmark x the store's CP ROs, minus the services it sold. Each service valued at the store's own labor + parts gross per service sold (group average where the store sold fewer than 30), capped at twice the group average because some flagged lines carry other work bundled on them. A year = Jan-Sep x 12 / 9. Stores at or above the benchmark are not shown and do not offset anyone. Tire Balance: every store, gross a year above (+) or below (-) the benchmark at the store's own gross per service. Rate = Jan-Sep closing %. Services = services a year above (+) or below (-) the benchmark (benchmark x CP ROs vs services sold, x 12/9).</a:t>
+              <a:t>Source: Qlik - Closed Repair Orders. Customer pay, Jan-Sep 2026 by close date, op code report basis. Same-store, INEOS excluded (opened 2026). Services short = benchmark x the store's CP ROs, minus the services it sold. Each service valued at the store's own labor + parts gross per service sold (group average where the store sold fewer than 30), capped at twice the group average because some flagged lines carry other work bundled on them. A year = Jan-Sep x 12 / 9. Stores at or above the benchmark are not shown and do not offset anyone. Tire Balance: every store, gross a year above (+) or below (-) the benchmark at the store's own gross per service. Rate = Jan-Sep closing %. Opcodes = opcodes a year above (+) or below (-) the benchmark (benchmark x CP ROs vs services sold, x 12/9).</a:t>
             </a:r>
             <a:endParaRPr lang="en-US" dirty="0"/>
           </a:p>
@@ -681,7 +681,7 @@
           <a:p>
             <a:r>
               <a:rPr lang="en-US" dirty="0"/>
-              <a:t>Source: Qlik - Closed Repair Orders. Customer pay, Jan-Sep 2026 by close date, op code report basis. Same-store, INEOS excluded (opened 2026). Services short = benchmark x the store's CP ROs, minus the services it sold. Each service valued at the store's own labor + parts gross per service sold (group average where the store sold fewer than 30), capped at twice the group average because some flagged lines carry other work bundled on them. A year = Jan-Sep x 12 / 9. Stores at or above the benchmark are not shown and do not offset anyone. Brake Fluid: every store, gross a year above (+) or below (-) the benchmark at the store's own gross per service. Rate = Jan-Sep closing %. Services = services a year above (+) or below (-) the benchmark (benchmark x CP ROs vs services sold, x 12/9).</a:t>
+              <a:t>Source: Qlik - Closed Repair Orders. Customer pay, Jan-Sep 2026 by close date, op code report basis. Same-store, INEOS excluded (opened 2026). Services short = benchmark x the store's CP ROs, minus the services it sold. Each service valued at the store's own labor + parts gross per service sold (group average where the store sold fewer than 30), capped at twice the group average because some flagged lines carry other work bundled on them. A year = Jan-Sep x 12 / 9. Stores at or above the benchmark are not shown and do not offset anyone. Brake Fluid: every store, gross a year above (+) or below (-) the benchmark at the store's own gross per service. Rate = Jan-Sep closing %. Opcodes = opcodes a year above (+) or below (-) the benchmark (benchmark x CP ROs vs services sold, x 12/9).</a:t>
             </a:r>
             <a:endParaRPr lang="en-US" dirty="0"/>
           </a:p>
@@ -769,7 +769,7 @@
           <a:p>
             <a:r>
               <a:rPr lang="en-US" dirty="0"/>
-              <a:t>Source: Qlik - Closed Repair Orders. Customer pay, Jan-Sep 2026 by close date, op code report basis. Same-store, INEOS excluded (opened 2026). Services short = benchmark x the store's CP ROs, minus the services it sold. Each service valued at the store's own labor + parts gross per service sold (group average where the store sold fewer than 30), capped at twice the group average because some flagged lines carry other work bundled on them. A year = Jan-Sep x 12 / 9. Stores at or above the benchmark are not shown and do not offset anyone. Fuel System Service: every store, gross a year above (+) or below (-) the benchmark at the store's own gross per service. Rate = Jan-Sep closing %. Services = services a year above (+) or below (-) the benchmark (benchmark x CP ROs vs services sold, x 12/9).</a:t>
+              <a:t>Source: Qlik - Closed Repair Orders. Customer pay, Jan-Sep 2026 by close date, op code report basis. Same-store, INEOS excluded (opened 2026). Services short = benchmark x the store's CP ROs, minus the services it sold. Each service valued at the store's own labor + parts gross per service sold (group average where the store sold fewer than 30), capped at twice the group average because some flagged lines carry other work bundled on them. A year = Jan-Sep x 12 / 9. Stores at or above the benchmark are not shown and do not offset anyone. Fuel System Service: every store, gross a year above (+) or below (-) the benchmark at the store's own gross per service. Rate = Jan-Sep closing %. Opcodes = opcodes a year above (+) or below (-) the benchmark (benchmark x CP ROs vs services sold, x 12/9).</a:t>
             </a:r>
             <a:endParaRPr lang="en-US" dirty="0"/>
           </a:p>
@@ -1371,7 +1371,7 @@
                 <a:ea typeface="Inter" pitchFamily="34" charset="-122"/>
                 <a:cs typeface="Inter" pitchFamily="34" charset="-120"/>
               </a:rPr>
-              <a:t>Services</a:t>
+              <a:t>Opcodes</a:t>
             </a:r>
             <a:endParaRPr lang="en-US" sz="1400" dirty="0"/>
           </a:p>
@@ -1508,7 +1508,7 @@
                 <a:ea typeface="Inter" pitchFamily="34" charset="-122"/>
                 <a:cs typeface="Inter" pitchFamily="34" charset="-120"/>
               </a:rPr>
-              <a:t>Services</a:t>
+              <a:t>Opcodes</a:t>
             </a:r>
             <a:endParaRPr lang="en-US" sz="1400" dirty="0"/>
           </a:p>
@@ -8969,7 +8969,7 @@
                 <a:ea typeface="Inter" pitchFamily="34" charset="-122"/>
                 <a:cs typeface="Inter" pitchFamily="34" charset="-120"/>
               </a:rPr>
-              <a:t>Services</a:t>
+              <a:t>Opcodes</a:t>
             </a:r>
             <a:endParaRPr lang="en-US" sz="1400" dirty="0"/>
           </a:p>
@@ -9106,7 +9106,7 @@
                 <a:ea typeface="Inter" pitchFamily="34" charset="-122"/>
                 <a:cs typeface="Inter" pitchFamily="34" charset="-120"/>
               </a:rPr>
-              <a:t>Services</a:t>
+              <a:t>Opcodes</a:t>
             </a:r>
             <a:endParaRPr lang="en-US" sz="1400" dirty="0"/>
           </a:p>
@@ -16567,7 +16567,7 @@
                 <a:ea typeface="Inter" pitchFamily="34" charset="-122"/>
                 <a:cs typeface="Inter" pitchFamily="34" charset="-120"/>
               </a:rPr>
-              <a:t>Services</a:t>
+              <a:t>Opcodes</a:t>
             </a:r>
             <a:endParaRPr lang="en-US" sz="1400" dirty="0"/>
           </a:p>
@@ -16704,7 +16704,7 @@
                 <a:ea typeface="Inter" pitchFamily="34" charset="-122"/>
                 <a:cs typeface="Inter" pitchFamily="34" charset="-120"/>
               </a:rPr>
-              <a:t>Services</a:t>
+              <a:t>Opcodes</a:t>
             </a:r>
             <a:endParaRPr lang="en-US" sz="1400" dirty="0"/>
           </a:p>
@@ -24165,7 +24165,7 @@
                 <a:ea typeface="Inter" pitchFamily="34" charset="-122"/>
                 <a:cs typeface="Inter" pitchFamily="34" charset="-120"/>
               </a:rPr>
-              <a:t>Services</a:t>
+              <a:t>Opcodes</a:t>
             </a:r>
             <a:endParaRPr lang="en-US" sz="1400" dirty="0"/>
           </a:p>
@@ -24302,7 +24302,7 @@
                 <a:ea typeface="Inter" pitchFamily="34" charset="-122"/>
                 <a:cs typeface="Inter" pitchFamily="34" charset="-120"/>
               </a:rPr>
-              <a:t>Services</a:t>
+              <a:t>Opcodes</a:t>
             </a:r>
             <a:endParaRPr lang="en-US" sz="1400" dirty="0"/>
           </a:p>

</xml_diff>